<commit_message>
Expand AI-driven development story with 3 new slides
Add slides: "This entire project was built by AI" (case study table
showing ORM, apps, CI, audit, fixes all AI-generated), "Why AI agents
need typed cross-compiled foundations" (conventional vs Temper cards),
and "Review once, ship to every platform" (12x vs 1x review burden).
Deck now 15 slides. Both HTML and PPTX updated.

Co-Authored-By: Claude Opus 4.6 <noreply@anthropic.com>
</commit_message>
<xml_diff>
--- a/deck.pptx
+++ b/deck.pptx
@@ -17,6 +17,9 @@
     <p:sldId id="265" r:id="rId16"/>
     <p:sldId id="266" r:id="rId17"/>
     <p:sldId id="267" r:id="rId18"/>
+    <p:sldId id="268" r:id="rId19"/>
+    <p:sldId id="269" r:id="rId20"/>
+    <p:sldId id="270" r:id="rId21"/>
   </p:sldIdLst>
   <p:sldSz cx="12191695" cy="6858000" type="screen4x3"/>
   <p:notesSz cx="6858000" cy="9144000"/>
@@ -3659,7 +3662,7 @@
                 </a:solidFill>
                 <a:latin typeface="Helvetica Neue"/>
               </a:rPr>
-              <a:t>AT SCALE</a:t>
+              <a:t>CASE STUDY</a:t>
             </a:r>
           </a:p>
         </p:txBody>
@@ -3701,7 +3704,7 @@
                 </a:solidFill>
                 <a:latin typeface="Helvetica Neue"/>
               </a:rPr>
-              <a:t>What if SDK security was a single source of truth?</a:t>
+              <a:t>This entire project was built by AI</a:t>
             </a:r>
           </a:p>
         </p:txBody>
@@ -3714,8 +3717,8 @@
         </p:nvSpPr>
         <p:spPr>
           <a:xfrm>
-            <a:off x="1828800" y="2011680"/>
-            <a:ext cx="3200400" cy="1280160"/>
+            <a:off x="731520" y="1645920"/>
+            <a:ext cx="10728655" cy="914400"/>
           </a:xfrm>
           <a:prstGeom prst="rect">
             <a:avLst/>
@@ -3728,7 +3731,7 @@
           </a:bodyPr>
           <a:lstStyle/>
           <a:p>
-            <a:pPr algn="ctr">
+            <a:pPr algn="l">
               <a:spcBef>
                 <a:spcPts val="0"/>
               </a:spcBef>
@@ -3737,46 +3740,551 @@
               </a:spcAft>
             </a:pPr>
             <a:r>
-              <a:rPr sz="6000" b="1" i="0">
-                <a:solidFill>
-                  <a:srgbClr val="000000"/>
-                </a:solidFill>
-                <a:latin typeface="Helvetica Neue"/>
-              </a:rPr>
-              <a:t>3,600</a:t>
-            </a:r>
-          </a:p>
-          <a:p>
-            <a:pPr algn="ctr">
-              <a:spcBef>
-                <a:spcPts val="400"/>
-              </a:spcBef>
-              <a:spcAft>
-                <a:spcPts val="0"/>
-              </a:spcAft>
-            </a:pPr>
-            <a:r>
-              <a:rPr sz="1200" b="0" i="0">
-                <a:solidFill>
-                  <a:srgbClr val="999999"/>
-                </a:solidFill>
-                <a:latin typeface="Helvetica Neue"/>
-              </a:rPr>
-              <a:t>libraries to patch today</a:t>
-            </a:r>
-          </a:p>
-        </p:txBody>
-      </p:sp>
-      <p:sp>
-        <p:nvSpPr>
-          <p:cNvPr id="5" name="TextBox 4"/>
+              <a:rPr sz="1600" b="0" i="0">
+                <a:solidFill>
+                  <a:srgbClr val="555555"/>
+                </a:solidFill>
+                <a:latin typeface="Helvetica Neue"/>
+              </a:rPr>
+              <a:t>Everything in this deck was produced by a single developer working with Claude. The ORM, the apps, the security analysis, the fixes, and this deck itself.</a:t>
+            </a:r>
+          </a:p>
+        </p:txBody>
+      </p:sp>
+      <p:graphicFrame>
+        <p:nvGraphicFramePr>
+          <p:cNvPr id="5" name="Table 4"/>
+          <p:cNvGraphicFramePr>
+            <a:graphicFrameLocks noGrp="1"/>
+          </p:cNvGraphicFramePr>
+          <p:nvPr/>
+        </p:nvGraphicFramePr>
+        <p:xfrm>
+          <a:off x="731520" y="2377440"/>
+          <a:ext cx="10728653" cy="2432304"/>
+        </p:xfrm>
+        <a:graphic>
+          <a:graphicData uri="http://schemas.openxmlformats.org/drawingml/2006/table">
+            <a:tbl>
+              <a:tblPr firstRow="1" bandRow="1">
+                <a:tableStyleId>{5C22544A-7EE6-4342-B048-85BDC9FD1C3A}</a:tableStyleId>
+              </a:tblPr>
+              <a:tblGrid>
+                <a:gridCol w="3004023"/>
+                <a:gridCol w="4076888"/>
+                <a:gridCol w="3647742"/>
+              </a:tblGrid>
+              <a:tr h="347472">
+                <a:tc>
+                  <a:txBody>
+                    <a:bodyPr/>
+                    <a:lstStyle/>
+                    <a:p>
+                      <a:pPr algn="l"/>
+                      <a:r>
+                        <a:rPr sz="1100" b="1">
+                          <a:solidFill>
+                            <a:srgbClr val="999999"/>
+                          </a:solidFill>
+                          <a:latin typeface="Helvetica Neue"/>
+                        </a:rPr>
+                        <a:t>What</a:t>
+                      </a:r>
+                    </a:p>
+                  </a:txBody>
+                  <a:tcPr>
+                    <a:solidFill>
+                      <a:srgbClr val="FFFFFF"/>
+                    </a:solidFill>
+                  </a:tcPr>
+                </a:tc>
+                <a:tc>
+                  <a:txBody>
+                    <a:bodyPr/>
+                    <a:lstStyle/>
+                    <a:p>
+                      <a:pPr algn="l"/>
+                      <a:r>
+                        <a:rPr sz="1100" b="1">
+                          <a:solidFill>
+                            <a:srgbClr val="999999"/>
+                          </a:solidFill>
+                          <a:latin typeface="Helvetica Neue"/>
+                        </a:rPr>
+                        <a:t>How</a:t>
+                      </a:r>
+                    </a:p>
+                  </a:txBody>
+                  <a:tcPr>
+                    <a:solidFill>
+                      <a:srgbClr val="FFFFFF"/>
+                    </a:solidFill>
+                  </a:tcPr>
+                </a:tc>
+                <a:tc>
+                  <a:txBody>
+                    <a:bodyPr/>
+                    <a:lstStyle/>
+                    <a:p>
+                      <a:pPr algn="l"/>
+                      <a:r>
+                        <a:rPr sz="1100" b="1">
+                          <a:solidFill>
+                            <a:srgbClr val="999999"/>
+                          </a:solidFill>
+                          <a:latin typeface="Helvetica Neue"/>
+                        </a:rPr>
+                        <a:t>Result</a:t>
+                      </a:r>
+                    </a:p>
+                  </a:txBody>
+                  <a:tcPr>
+                    <a:solidFill>
+                      <a:srgbClr val="FFFFFF"/>
+                    </a:solidFill>
+                  </a:tcPr>
+                </a:tc>
+              </a:tr>
+              <a:tr h="347472">
+                <a:tc>
+                  <a:txBody>
+                    <a:bodyPr/>
+                    <a:lstStyle/>
+                    <a:p>
+                      <a:pPr algn="l"/>
+                      <a:r>
+                        <a:rPr sz="1300" b="0">
+                          <a:solidFill>
+                            <a:srgbClr val="555555"/>
+                          </a:solidFill>
+                          <a:latin typeface="Helvetica Neue"/>
+                        </a:rPr>
+                        <a:t>ORM source (Temper)</a:t>
+                      </a:r>
+                    </a:p>
+                  </a:txBody>
+                  <a:tcPr>
+                    <a:solidFill>
+                      <a:srgbClr val="FFFFFF"/>
+                    </a:solidFill>
+                  </a:tcPr>
+                </a:tc>
+                <a:tc>
+                  <a:txBody>
+                    <a:bodyPr/>
+                    <a:lstStyle/>
+                    <a:p>
+                      <a:pPr algn="l"/>
+                      <a:r>
+                        <a:rPr sz="1300" b="0">
+                          <a:solidFill>
+                            <a:srgbClr val="555555"/>
+                          </a:solidFill>
+                          <a:latin typeface="Helvetica Neue"/>
+                        </a:rPr>
+                        <a:t>AI-generated with iterative prompts</a:t>
+                      </a:r>
+                    </a:p>
+                  </a:txBody>
+                  <a:tcPr>
+                    <a:solidFill>
+                      <a:srgbClr val="FFFFFF"/>
+                    </a:solidFill>
+                  </a:tcPr>
+                </a:tc>
+                <a:tc>
+                  <a:txBody>
+                    <a:bodyPr/>
+                    <a:lstStyle/>
+                    <a:p>
+                      <a:pPr algn="l"/>
+                      <a:r>
+                        <a:rPr sz="1300" b="0">
+                          <a:solidFill>
+                            <a:srgbClr val="555555"/>
+                          </a:solidFill>
+                          <a:latin typeface="Helvetica Neue"/>
+                        </a:rPr>
+                        <a:t>5 defense layers, 56 tests, 0 vulns</a:t>
+                      </a:r>
+                    </a:p>
+                  </a:txBody>
+                  <a:tcPr>
+                    <a:solidFill>
+                      <a:srgbClr val="FFFFFF"/>
+                    </a:solidFill>
+                  </a:tcPr>
+                </a:tc>
+              </a:tr>
+              <a:tr h="347472">
+                <a:tc>
+                  <a:txBody>
+                    <a:bodyPr/>
+                    <a:lstStyle/>
+                    <a:p>
+                      <a:pPr algn="l"/>
+                      <a:r>
+                        <a:rPr sz="1300" b="0">
+                          <a:solidFill>
+                            <a:srgbClr val="555555"/>
+                          </a:solidFill>
+                          <a:latin typeface="Helvetica Neue"/>
+                        </a:rPr>
+                        <a:t>6 todo-list applications</a:t>
+                      </a:r>
+                    </a:p>
+                  </a:txBody>
+                  <a:tcPr>
+                    <a:solidFill>
+                      <a:srgbClr val="FFFFFF"/>
+                    </a:solidFill>
+                  </a:tcPr>
+                </a:tc>
+                <a:tc>
+                  <a:txBody>
+                    <a:bodyPr/>
+                    <a:lstStyle/>
+                    <a:p>
+                      <a:pPr algn="l"/>
+                      <a:r>
+                        <a:rPr sz="1300" b="0">
+                          <a:solidFill>
+                            <a:srgbClr val="555555"/>
+                          </a:solidFill>
+                          <a:latin typeface="Helvetica Neue"/>
+                        </a:rPr>
+                        <a:t>AI-generated per language</a:t>
+                      </a:r>
+                    </a:p>
+                  </a:txBody>
+                  <a:tcPr>
+                    <a:solidFill>
+                      <a:srgbClr val="FFFFFF"/>
+                    </a:solidFill>
+                  </a:tcPr>
+                </a:tc>
+                <a:tc>
+                  <a:txBody>
+                    <a:bodyPr/>
+                    <a:lstStyle/>
+                    <a:p>
+                      <a:pPr algn="l"/>
+                      <a:r>
+                        <a:rPr sz="1300" b="0">
+                          <a:solidFill>
+                            <a:srgbClr val="555555"/>
+                          </a:solidFill>
+                          <a:latin typeface="Helvetica Neue"/>
+                        </a:rPr>
+                        <a:t>6 frameworks, identical functionality</a:t>
+                      </a:r>
+                    </a:p>
+                  </a:txBody>
+                  <a:tcPr>
+                    <a:solidFill>
+                      <a:srgbClr val="FFFFFF"/>
+                    </a:solidFill>
+                  </a:tcPr>
+                </a:tc>
+              </a:tr>
+              <a:tr h="347472">
+                <a:tc>
+                  <a:txBody>
+                    <a:bodyPr/>
+                    <a:lstStyle/>
+                    <a:p>
+                      <a:pPr algn="l"/>
+                      <a:r>
+                        <a:rPr sz="1300" b="0">
+                          <a:solidFill>
+                            <a:srgbClr val="555555"/>
+                          </a:solidFill>
+                          <a:latin typeface="Helvetica Neue"/>
+                        </a:rPr>
+                        <a:t>CI/CD pipeline</a:t>
+                      </a:r>
+                    </a:p>
+                  </a:txBody>
+                  <a:tcPr>
+                    <a:solidFill>
+                      <a:srgbClr val="FFFFFF"/>
+                    </a:solidFill>
+                  </a:tcPr>
+                </a:tc>
+                <a:tc>
+                  <a:txBody>
+                    <a:bodyPr/>
+                    <a:lstStyle/>
+                    <a:p>
+                      <a:pPr algn="l"/>
+                      <a:r>
+                        <a:rPr sz="1300" b="0">
+                          <a:solidFill>
+                            <a:srgbClr val="555555"/>
+                          </a:solidFill>
+                          <a:latin typeface="Helvetica Neue"/>
+                        </a:rPr>
+                        <a:t>AI-generated GitHub Actions</a:t>
+                      </a:r>
+                    </a:p>
+                  </a:txBody>
+                  <a:tcPr>
+                    <a:solidFill>
+                      <a:srgbClr val="FFFFFF"/>
+                    </a:solidFill>
+                  </a:tcPr>
+                </a:tc>
+                <a:tc>
+                  <a:txBody>
+                    <a:bodyPr/>
+                    <a:lstStyle/>
+                    <a:p>
+                      <a:pPr algn="l"/>
+                      <a:r>
+                        <a:rPr sz="1300" b="0">
+                          <a:solidFill>
+                            <a:srgbClr val="555555"/>
+                          </a:solidFill>
+                          <a:latin typeface="Helvetica Neue"/>
+                        </a:rPr>
+                        <a:t>12 repos, automated cascade</a:t>
+                      </a:r>
+                    </a:p>
+                  </a:txBody>
+                  <a:tcPr>
+                    <a:solidFill>
+                      <a:srgbClr val="FFFFFF"/>
+                    </a:solidFill>
+                  </a:tcPr>
+                </a:tc>
+              </a:tr>
+              <a:tr h="347472">
+                <a:tc>
+                  <a:txBody>
+                    <a:bodyPr/>
+                    <a:lstStyle/>
+                    <a:p>
+                      <a:pPr algn="l"/>
+                      <a:r>
+                        <a:rPr sz="1300" b="0">
+                          <a:solidFill>
+                            <a:srgbClr val="555555"/>
+                          </a:solidFill>
+                          <a:latin typeface="Helvetica Neue"/>
+                        </a:rPr>
+                        <a:t>MITRE/CWE security audit</a:t>
+                      </a:r>
+                    </a:p>
+                  </a:txBody>
+                  <a:tcPr>
+                    <a:solidFill>
+                      <a:srgbClr val="FFFFFF"/>
+                    </a:solidFill>
+                  </a:tcPr>
+                </a:tc>
+                <a:tc>
+                  <a:txBody>
+                    <a:bodyPr/>
+                    <a:lstStyle/>
+                    <a:p>
+                      <a:pPr algn="l"/>
+                      <a:r>
+                        <a:rPr sz="1300" b="0">
+                          <a:solidFill>
+                            <a:srgbClr val="555555"/>
+                          </a:solidFill>
+                          <a:latin typeface="Helvetica Neue"/>
+                        </a:rPr>
+                        <a:t>AI-conducted analysis</a:t>
+                      </a:r>
+                    </a:p>
+                  </a:txBody>
+                  <a:tcPr>
+                    <a:solidFill>
+                      <a:srgbClr val="FFFFFF"/>
+                    </a:solidFill>
+                  </a:tcPr>
+                </a:tc>
+                <a:tc>
+                  <a:txBody>
+                    <a:bodyPr/>
+                    <a:lstStyle/>
+                    <a:p>
+                      <a:pPr algn="l"/>
+                      <a:r>
+                        <a:rPr sz="1300" b="0">
+                          <a:solidFill>
+                            <a:srgbClr val="555555"/>
+                          </a:solidFill>
+                          <a:latin typeface="Helvetica Neue"/>
+                        </a:rPr>
+                        <a:t>4 ORM findings, 0 app-level injection</a:t>
+                      </a:r>
+                    </a:p>
+                  </a:txBody>
+                  <a:tcPr>
+                    <a:solidFill>
+                      <a:srgbClr val="FFFFFF"/>
+                    </a:solidFill>
+                  </a:tcPr>
+                </a:tc>
+              </a:tr>
+              <a:tr h="347472">
+                <a:tc>
+                  <a:txBody>
+                    <a:bodyPr/>
+                    <a:lstStyle/>
+                    <a:p>
+                      <a:pPr algn="l"/>
+                      <a:r>
+                        <a:rPr sz="1300" b="0">
+                          <a:solidFill>
+                            <a:srgbClr val="555555"/>
+                          </a:solidFill>
+                          <a:latin typeface="Helvetica Neue"/>
+                        </a:rPr>
+                        <a:t>Bug fixes (ORM-1/2/3)</a:t>
+                      </a:r>
+                    </a:p>
+                  </a:txBody>
+                  <a:tcPr>
+                    <a:solidFill>
+                      <a:srgbClr val="FFFFFF"/>
+                    </a:solidFill>
+                  </a:tcPr>
+                </a:tc>
+                <a:tc>
+                  <a:txBody>
+                    <a:bodyPr/>
+                    <a:lstStyle/>
+                    <a:p>
+                      <a:pPr algn="l"/>
+                      <a:r>
+                        <a:rPr sz="1300" b="0">
+                          <a:solidFill>
+                            <a:srgbClr val="555555"/>
+                          </a:solidFill>
+                          <a:latin typeface="Helvetica Neue"/>
+                        </a:rPr>
+                        <a:t>AI-identified and AI-fixed</a:t>
+                      </a:r>
+                    </a:p>
+                  </a:txBody>
+                  <a:tcPr>
+                    <a:solidFill>
+                      <a:srgbClr val="FFFFFF"/>
+                    </a:solidFill>
+                  </a:tcPr>
+                </a:tc>
+                <a:tc>
+                  <a:txBody>
+                    <a:bodyPr/>
+                    <a:lstStyle/>
+                    <a:p>
+                      <a:pPr algn="l"/>
+                      <a:r>
+                        <a:rPr sz="1300" b="0">
+                          <a:solidFill>
+                            <a:srgbClr val="555555"/>
+                          </a:solidFill>
+                          <a:latin typeface="Helvetica Neue"/>
+                        </a:rPr>
+                        <a:t>1 commit, 6 backends patched</a:t>
+                      </a:r>
+                    </a:p>
+                  </a:txBody>
+                  <a:tcPr>
+                    <a:solidFill>
+                      <a:srgbClr val="FFFFFF"/>
+                    </a:solidFill>
+                  </a:tcPr>
+                </a:tc>
+              </a:tr>
+              <a:tr h="347472">
+                <a:tc>
+                  <a:txBody>
+                    <a:bodyPr/>
+                    <a:lstStyle/>
+                    <a:p>
+                      <a:pPr algn="l"/>
+                      <a:r>
+                        <a:rPr sz="1300" b="0">
+                          <a:solidFill>
+                            <a:srgbClr val="555555"/>
+                          </a:solidFill>
+                          <a:latin typeface="Helvetica Neue"/>
+                        </a:rPr>
+                        <a:t>Verification</a:t>
+                      </a:r>
+                    </a:p>
+                  </a:txBody>
+                  <a:tcPr>
+                    <a:solidFill>
+                      <a:srgbClr val="FFFFFF"/>
+                    </a:solidFill>
+                  </a:tcPr>
+                </a:tc>
+                <a:tc>
+                  <a:txBody>
+                    <a:bodyPr/>
+                    <a:lstStyle/>
+                    <a:p>
+                      <a:pPr algn="l"/>
+                      <a:r>
+                        <a:rPr sz="1300" b="0">
+                          <a:solidFill>
+                            <a:srgbClr val="555555"/>
+                          </a:solidFill>
+                          <a:latin typeface="Helvetica Neue"/>
+                        </a:rPr>
+                        <a:t>AI grepped compiled output</a:t>
+                      </a:r>
+                    </a:p>
+                  </a:txBody>
+                  <a:tcPr>
+                    <a:solidFill>
+                      <a:srgbClr val="FFFFFF"/>
+                    </a:solidFill>
+                  </a:tcPr>
+                </a:tc>
+                <a:tc>
+                  <a:txBody>
+                    <a:bodyPr/>
+                    <a:lstStyle/>
+                    <a:p>
+                      <a:pPr algn="l"/>
+                      <a:r>
+                        <a:rPr sz="1300" b="0">
+                          <a:solidFill>
+                            <a:srgbClr val="555555"/>
+                          </a:solidFill>
+                          <a:latin typeface="Helvetica Neue"/>
+                        </a:rPr>
+                        <a:t>Fixes confirmed in all backends</a:t>
+                      </a:r>
+                    </a:p>
+                  </a:txBody>
+                  <a:tcPr>
+                    <a:solidFill>
+                      <a:srgbClr val="FFFFFF"/>
+                    </a:solidFill>
+                  </a:tcPr>
+                </a:tc>
+              </a:tr>
+            </a:tbl>
+          </a:graphicData>
+        </a:graphic>
+      </p:graphicFrame>
+      <p:sp>
+        <p:nvSpPr>
+          <p:cNvPr id="6" name="TextBox 5"/>
           <p:cNvSpPr txBox="1"/>
           <p:nvPr/>
         </p:nvSpPr>
         <p:spPr>
           <a:xfrm>
-            <a:off x="5303520" y="2194560"/>
-            <a:ext cx="1371600" cy="548640"/>
+            <a:off x="731520" y="5486400"/>
+            <a:ext cx="10728655" cy="914400"/>
           </a:xfrm>
           <a:prstGeom prst="rect">
             <a:avLst/>
@@ -3789,7 +4297,7 @@
           </a:bodyPr>
           <a:lstStyle/>
           <a:p>
-            <a:pPr algn="ctr">
+            <a:pPr algn="l">
               <a:spcBef>
                 <a:spcPts val="0"/>
               </a:spcBef>
@@ -3798,108 +4306,32 @@
               </a:spcAft>
             </a:pPr>
             <a:r>
-              <a:rPr sz="3600" b="0" i="0">
-                <a:solidFill>
-                  <a:srgbClr val="DDDDDD"/>
-                </a:solidFill>
-                <a:latin typeface="Helvetica Neue"/>
-              </a:rPr>
-              <a:t>→</a:t>
-            </a:r>
-          </a:p>
-        </p:txBody>
-      </p:sp>
-      <p:sp>
-        <p:nvSpPr>
-          <p:cNvPr id="6" name="TextBox 5"/>
-          <p:cNvSpPr txBox="1"/>
-          <p:nvPr/>
-        </p:nvSpPr>
-        <p:spPr>
-          <a:xfrm>
-            <a:off x="7132320" y="2011680"/>
-            <a:ext cx="3200400" cy="1280160"/>
-          </a:xfrm>
-          <a:prstGeom prst="rect">
-            <a:avLst/>
-          </a:prstGeom>
-          <a:noFill/>
-        </p:spPr>
-        <p:txBody>
-          <a:bodyPr wrap="square">
-            <a:spAutoFit/>
-          </a:bodyPr>
-          <a:lstStyle/>
-          <a:p>
-            <a:pPr algn="ctr">
-              <a:spcBef>
-                <a:spcPts val="0"/>
-              </a:spcBef>
-              <a:spcAft>
-                <a:spcPts val="0"/>
-              </a:spcAft>
-            </a:pPr>
-            <a:r>
-              <a:rPr sz="6000" b="1" i="0">
+              <a:rPr sz="1800" b="0" i="0">
+                <a:solidFill>
+                  <a:srgbClr val="555555"/>
+                </a:solidFill>
+                <a:latin typeface="Helvetica Neue"/>
+              </a:rPr>
+              <a:t/>
+            </a:r>
+            <a:r>
+              <a:rPr sz="1600" b="0" i="0">
+                <a:solidFill>
+                  <a:srgbClr val="555555"/>
+                </a:solidFill>
+                <a:latin typeface="Helvetica Neue"/>
+              </a:rPr>
+              <a:t>The AI did not need to know 6 languages to secure 6 backends. It worked in </a:t>
+            </a:r>
+            <a:r>
+              <a:rPr sz="1600" b="1" i="0">
                 <a:solidFill>
                   <a:srgbClr val="000000"/>
                 </a:solidFill>
                 <a:latin typeface="Helvetica Neue"/>
               </a:rPr>
-              <a:t>300</a:t>
-            </a:r>
-          </a:p>
-          <a:p>
-            <a:pPr algn="ctr">
-              <a:spcBef>
-                <a:spcPts val="400"/>
-              </a:spcBef>
-              <a:spcAft>
-                <a:spcPts val="0"/>
-              </a:spcAft>
-            </a:pPr>
-            <a:r>
-              <a:rPr sz="1200" b="0" i="0">
-                <a:solidFill>
-                  <a:srgbClr val="999999"/>
-                </a:solidFill>
-                <a:latin typeface="Helvetica Neue"/>
-              </a:rPr>
-              <a:t>Temper sources to maintain</a:t>
-            </a:r>
-          </a:p>
-        </p:txBody>
-      </p:sp>
-      <p:sp>
-        <p:nvSpPr>
-          <p:cNvPr id="7" name="TextBox 6"/>
-          <p:cNvSpPr txBox="1"/>
-          <p:nvPr/>
-        </p:nvSpPr>
-        <p:spPr>
-          <a:xfrm>
-            <a:off x="731520" y="3657600"/>
-            <a:ext cx="10728655" cy="914400"/>
-          </a:xfrm>
-          <a:prstGeom prst="rect">
-            <a:avLst/>
-          </a:prstGeom>
-          <a:noFill/>
-        </p:spPr>
-        <p:txBody>
-          <a:bodyPr wrap="square">
-            <a:spAutoFit/>
-          </a:bodyPr>
-          <a:lstStyle/>
-          <a:p>
-            <a:pPr algn="l">
-              <a:spcBef>
-                <a:spcPts val="0"/>
-              </a:spcBef>
-              <a:spcAft>
-                <a:spcPts val="0"/>
-              </a:spcAft>
-            </a:pPr>
+              <a:t>one language</a:t>
+            </a:r>
             <a:r>
               <a:rPr sz="1600" b="0" i="0">
                 <a:solidFill>
@@ -3907,156 +4339,7 @@
                 </a:solidFill>
                 <a:latin typeface="Helvetica Neue"/>
               </a:rPr>
-              <a:t>AWS manages 300+ services across 12 languages. A single vulnerability requires coordinated patches across:</a:t>
-            </a:r>
-          </a:p>
-        </p:txBody>
-      </p:sp>
-      <p:sp>
-        <p:nvSpPr>
-          <p:cNvPr id="8" name="TextBox 7"/>
-          <p:cNvSpPr txBox="1"/>
-          <p:nvPr/>
-        </p:nvSpPr>
-        <p:spPr>
-          <a:xfrm>
-            <a:off x="914400" y="4297680"/>
-            <a:ext cx="10545775" cy="1371600"/>
-          </a:xfrm>
-          <a:prstGeom prst="rect">
-            <a:avLst/>
-          </a:prstGeom>
-          <a:noFill/>
-        </p:spPr>
-        <p:txBody>
-          <a:bodyPr wrap="square">
-            <a:spAutoFit/>
-          </a:bodyPr>
-          <a:lstStyle/>
-          <a:p>
-            <a:pPr algn="l">
-              <a:spcBef>
-                <a:spcPts val="0"/>
-              </a:spcBef>
-              <a:spcAft>
-                <a:spcPts val="400"/>
-              </a:spcAft>
-            </a:pPr>
-            <a:r>
-              <a:rPr sz="1400" b="0" i="0">
-                <a:solidFill>
-                  <a:srgbClr val="555555"/>
-                </a:solidFill>
-                <a:latin typeface="Helvetica Neue"/>
-              </a:rPr>
-              <a:t>—  12 SDK repositories with independent release cycles</a:t>
-            </a:r>
-          </a:p>
-          <a:p>
-            <a:pPr algn="l">
-              <a:spcBef>
-                <a:spcPts val="0"/>
-              </a:spcBef>
-              <a:spcAft>
-                <a:spcPts val="400"/>
-              </a:spcAft>
-            </a:pPr>
-            <a:r>
-              <a:rPr sz="1400" b="0" i="0">
-                <a:solidFill>
-                  <a:srgbClr val="555555"/>
-                </a:solidFill>
-                <a:latin typeface="Helvetica Neue"/>
-              </a:rPr>
-              <a:t>—  8+ package registries (npm, PyPI, Maven, NuGet, crates.io, RubyGems, Packagist, Go proxy)</a:t>
-            </a:r>
-          </a:p>
-          <a:p>
-            <a:pPr algn="l">
-              <a:spcBef>
-                <a:spcPts val="0"/>
-              </a:spcBef>
-              <a:spcAft>
-                <a:spcPts val="400"/>
-              </a:spcAft>
-            </a:pPr>
-            <a:r>
-              <a:rPr sz="1400" b="0" i="0">
-                <a:solidFill>
-                  <a:srgbClr val="555555"/>
-                </a:solidFill>
-                <a:latin typeface="Helvetica Neue"/>
-              </a:rPr>
-              <a:t>—  Daily releases that must be synchronized</a:t>
-            </a:r>
-          </a:p>
-        </p:txBody>
-      </p:sp>
-      <p:sp>
-        <p:nvSpPr>
-          <p:cNvPr id="9" name="TextBox 8"/>
-          <p:cNvSpPr txBox="1"/>
-          <p:nvPr/>
-        </p:nvSpPr>
-        <p:spPr>
-          <a:xfrm>
-            <a:off x="731520" y="5486400"/>
-            <a:ext cx="10728655" cy="914400"/>
-          </a:xfrm>
-          <a:prstGeom prst="rect">
-            <a:avLst/>
-          </a:prstGeom>
-          <a:noFill/>
-        </p:spPr>
-        <p:txBody>
-          <a:bodyPr wrap="square">
-            <a:spAutoFit/>
-          </a:bodyPr>
-          <a:lstStyle/>
-          <a:p>
-            <a:pPr algn="l">
-              <a:spcBef>
-                <a:spcPts val="0"/>
-              </a:spcBef>
-              <a:spcAft>
-                <a:spcPts val="0"/>
-              </a:spcAft>
-            </a:pPr>
-            <a:r>
-              <a:rPr sz="1800" b="0" i="0">
-                <a:solidFill>
-                  <a:srgbClr val="555555"/>
-                </a:solidFill>
-                <a:latin typeface="Helvetica Neue"/>
-              </a:rPr>
-              <a:t/>
-            </a:r>
-            <a:r>
-              <a:rPr sz="1600" b="0" i="0">
-                <a:solidFill>
-                  <a:srgbClr val="555555"/>
-                </a:solidFill>
-                <a:latin typeface="Helvetica Neue"/>
-              </a:rPr>
-              <a:t>With Temper, security logic lives in </a:t>
-            </a:r>
-            <a:r>
-              <a:rPr sz="1600" b="1" i="0">
-                <a:solidFill>
-                  <a:srgbClr val="000000"/>
-                </a:solidFill>
-                <a:latin typeface="Helvetica Neue"/>
-              </a:rPr>
-              <a:t>one place</a:t>
-            </a:r>
-            <a:r>
-              <a:rPr sz="1600" b="0" i="0">
-                <a:solidFill>
-                  <a:srgbClr val="555555"/>
-                </a:solidFill>
-                <a:latin typeface="Helvetica Neue"/>
-              </a:rPr>
-              <a:t>. A fix compiles to all targets in a single build. No coordination. No drift.</a:t>
+              <a:t> and the compiler did the rest. This is the workflow AI-driven development needs.</a:t>
             </a:r>
           </a:p>
         </p:txBody>
@@ -4116,7 +4399,7 @@
                 </a:solidFill>
                 <a:latin typeface="Helvetica Neue"/>
               </a:rPr>
-              <a:t>BEYOND THIS DEMO</a:t>
+              <a:t>THE AI WORKFLOW</a:t>
             </a:r>
           </a:p>
         </p:txBody>
@@ -4158,21 +4441,63 @@
                 </a:solidFill>
                 <a:latin typeface="Helvetica Neue"/>
               </a:rPr>
-              <a:t>Where Temper changes the game</a:t>
-            </a:r>
-          </a:p>
-        </p:txBody>
-      </p:sp>
-      <p:sp>
-        <p:nvSpPr>
-          <p:cNvPr id="4" name="Rectangle 3"/>
+              <a:t>Why AI agents need typed, cross-compiled foundations</a:t>
+            </a:r>
+          </a:p>
+        </p:txBody>
+      </p:sp>
+      <p:sp>
+        <p:nvSpPr>
+          <p:cNvPr id="4" name="TextBox 3"/>
+          <p:cNvSpPr txBox="1"/>
+          <p:nvPr/>
+        </p:nvSpPr>
+        <p:spPr>
+          <a:xfrm>
+            <a:off x="731520" y="1645920"/>
+            <a:ext cx="10728655" cy="914400"/>
+          </a:xfrm>
+          <a:prstGeom prst="rect">
+            <a:avLst/>
+          </a:prstGeom>
+          <a:noFill/>
+        </p:spPr>
+        <p:txBody>
+          <a:bodyPr wrap="square">
+            <a:spAutoFit/>
+          </a:bodyPr>
+          <a:lstStyle/>
+          <a:p>
+            <a:pPr algn="l">
+              <a:spcBef>
+                <a:spcPts val="0"/>
+              </a:spcBef>
+              <a:spcAft>
+                <a:spcPts val="0"/>
+              </a:spcAft>
+            </a:pPr>
+            <a:r>
+              <a:rPr sz="1600" b="0" i="0">
+                <a:solidFill>
+                  <a:srgbClr val="555555"/>
+                </a:solidFill>
+                <a:latin typeface="Helvetica Neue"/>
+              </a:rPr>
+              <a:t>As AI coding agents move from autocomplete to autonomous engineering, the infrastructure they build on determines whether their output is safe at scale.</a:t>
+            </a:r>
+          </a:p>
+        </p:txBody>
+      </p:sp>
+      <p:sp>
+        <p:nvSpPr>
+          <p:cNvPr id="5" name="Rectangle 4"/>
           <p:cNvSpPr/>
           <p:nvPr/>
         </p:nvSpPr>
         <p:spPr>
           <a:xfrm>
-            <a:off x="731520" y="1828800"/>
-            <a:ext cx="5120640" cy="1828800"/>
+            <a:off x="731520" y="2377440"/>
+            <a:ext cx="5120640" cy="2743200"/>
           </a:xfrm>
           <a:prstGeom prst="rect">
             <a:avLst/>
@@ -4210,13 +4535,13 @@
       </p:sp>
       <p:sp>
         <p:nvSpPr>
-          <p:cNvPr id="5" name="TextBox 4"/>
+          <p:cNvPr id="6" name="TextBox 5"/>
           <p:cNvSpPr txBox="1"/>
           <p:nvPr/>
         </p:nvSpPr>
         <p:spPr>
           <a:xfrm>
-            <a:off x="960120" y="2011680"/>
+            <a:off x="960120" y="2560320"/>
             <a:ext cx="4663440" cy="365760"/>
           </a:xfrm>
           <a:prstGeom prst="rect">
@@ -4239,27 +4564,27 @@
               </a:spcAft>
             </a:pPr>
             <a:r>
-              <a:rPr sz="1600" b="1" i="0">
+              <a:rPr sz="1400" b="1" i="0">
                 <a:solidFill>
                   <a:srgbClr val="111111"/>
                 </a:solidFill>
                 <a:latin typeface="Helvetica Neue"/>
               </a:rPr>
-              <a:t>SDK Libraries</a:t>
-            </a:r>
-          </a:p>
-        </p:txBody>
-      </p:sp>
-      <p:sp>
-        <p:nvSpPr>
-          <p:cNvPr id="6" name="TextBox 5"/>
+              <a:t>The problem with AI + conventional languages</a:t>
+            </a:r>
+          </a:p>
+        </p:txBody>
+      </p:sp>
+      <p:sp>
+        <p:nvSpPr>
+          <p:cNvPr id="7" name="TextBox 6"/>
           <p:cNvSpPr txBox="1"/>
           <p:nvPr/>
         </p:nvSpPr>
         <p:spPr>
           <a:xfrm>
-            <a:off x="960120" y="2468880"/>
-            <a:ext cx="4663440" cy="1097280"/>
+            <a:off x="960120" y="3017520"/>
+            <a:ext cx="4663440" cy="2011680"/>
           </a:xfrm>
           <a:prstGeom prst="rect">
             <a:avLst/>
@@ -4277,31 +4602,107 @@
                 <a:spcPts val="0"/>
               </a:spcBef>
               <a:spcAft>
-                <a:spcPts val="0"/>
+                <a:spcPts val="400"/>
               </a:spcAft>
             </a:pPr>
             <a:r>
-              <a:rPr sz="1300" b="0" i="0">
+              <a:rPr sz="1200" b="0" i="0">
                 <a:solidFill>
                   <a:srgbClr val="555555"/>
                 </a:solidFill>
                 <a:latin typeface="Helvetica Neue"/>
               </a:rPr>
-              <a:t>API clients, serialization, auth flows, retry logic — write once, ship to every language your customers use.</a:t>
-            </a:r>
-          </a:p>
-        </p:txBody>
-      </p:sp>
-      <p:sp>
-        <p:nvSpPr>
-          <p:cNvPr id="7" name="Rectangle 6"/>
+              <a:t>—  AI generates idiomatic code — including idiomatic mistakes</a:t>
+            </a:r>
+          </a:p>
+          <a:p>
+            <a:pPr algn="l">
+              <a:spcBef>
+                <a:spcPts val="0"/>
+              </a:spcBef>
+              <a:spcAft>
+                <a:spcPts val="400"/>
+              </a:spcAft>
+            </a:pPr>
+            <a:r>
+              <a:rPr sz="1200" b="0" i="0">
+                <a:solidFill>
+                  <a:srgbClr val="555555"/>
+                </a:solidFill>
+                <a:latin typeface="Helvetica Neue"/>
+              </a:rPr>
+              <a:t>—  Ruby, Python, JS all allow raw string SQL with zero friction</a:t>
+            </a:r>
+          </a:p>
+          <a:p>
+            <a:pPr algn="l">
+              <a:spcBef>
+                <a:spcPts val="0"/>
+              </a:spcBef>
+              <a:spcAft>
+                <a:spcPts val="400"/>
+              </a:spcAft>
+            </a:pPr>
+            <a:r>
+              <a:rPr sz="1200" b="0" i="0">
+                <a:solidFill>
+                  <a:srgbClr val="555555"/>
+                </a:solidFill>
+                <a:latin typeface="Helvetica Neue"/>
+              </a:rPr>
+              <a:t>—  An agent building SDKs must learn security patterns per language</a:t>
+            </a:r>
+          </a:p>
+          <a:p>
+            <a:pPr algn="l">
+              <a:spcBef>
+                <a:spcPts val="0"/>
+              </a:spcBef>
+              <a:spcAft>
+                <a:spcPts val="400"/>
+              </a:spcAft>
+            </a:pPr>
+            <a:r>
+              <a:rPr sz="1200" b="0" i="0">
+                <a:solidFill>
+                  <a:srgbClr val="555555"/>
+                </a:solidFill>
+                <a:latin typeface="Helvetica Neue"/>
+              </a:rPr>
+              <a:t>—  Review burden multiplies: N languages × M agents × K services</a:t>
+            </a:r>
+          </a:p>
+          <a:p>
+            <a:pPr algn="l">
+              <a:spcBef>
+                <a:spcPts val="0"/>
+              </a:spcBef>
+              <a:spcAft>
+                <a:spcPts val="400"/>
+              </a:spcAft>
+            </a:pPr>
+            <a:r>
+              <a:rPr sz="1200" b="0" i="0">
+                <a:solidFill>
+                  <a:srgbClr val="555555"/>
+                </a:solidFill>
+                <a:latin typeface="Helvetica Neue"/>
+              </a:rPr>
+              <a:t>—  A single missed escaping call in one language = a CVE</a:t>
+            </a:r>
+          </a:p>
+        </p:txBody>
+      </p:sp>
+      <p:sp>
+        <p:nvSpPr>
+          <p:cNvPr id="8" name="Rectangle 7"/>
           <p:cNvSpPr/>
           <p:nvPr/>
         </p:nvSpPr>
         <p:spPr>
           <a:xfrm>
-            <a:off x="6400800" y="1828800"/>
-            <a:ext cx="5120640" cy="1828800"/>
+            <a:off x="6400800" y="2377440"/>
+            <a:ext cx="5120640" cy="2743200"/>
           </a:xfrm>
           <a:prstGeom prst="rect">
             <a:avLst/>
@@ -4339,13 +4740,13 @@
       </p:sp>
       <p:sp>
         <p:nvSpPr>
-          <p:cNvPr id="8" name="TextBox 7"/>
+          <p:cNvPr id="9" name="TextBox 8"/>
           <p:cNvSpPr txBox="1"/>
           <p:nvPr/>
         </p:nvSpPr>
         <p:spPr>
           <a:xfrm>
-            <a:off x="6629400" y="2011680"/>
+            <a:off x="6629400" y="2560320"/>
             <a:ext cx="4663440" cy="365760"/>
           </a:xfrm>
           <a:prstGeom prst="rect">
@@ -4368,27 +4769,27 @@
               </a:spcAft>
             </a:pPr>
             <a:r>
-              <a:rPr sz="1600" b="1" i="0">
+              <a:rPr sz="1400" b="1" i="0">
                 <a:solidFill>
                   <a:srgbClr val="111111"/>
                 </a:solidFill>
                 <a:latin typeface="Helvetica Neue"/>
               </a:rPr>
-              <a:t>Security Primitives</a:t>
-            </a:r>
-          </a:p>
-        </p:txBody>
-      </p:sp>
-      <p:sp>
-        <p:nvSpPr>
-          <p:cNvPr id="9" name="TextBox 8"/>
+              <a:t>The advantage of AI + Temper</a:t>
+            </a:r>
+          </a:p>
+        </p:txBody>
+      </p:sp>
+      <p:sp>
+        <p:nvSpPr>
+          <p:cNvPr id="10" name="TextBox 9"/>
           <p:cNvSpPr txBox="1"/>
           <p:nvPr/>
         </p:nvSpPr>
         <p:spPr>
           <a:xfrm>
-            <a:off x="6629400" y="2468880"/>
-            <a:ext cx="4663440" cy="1097280"/>
+            <a:off x="6629400" y="3017520"/>
+            <a:ext cx="4663440" cy="2011680"/>
           </a:xfrm>
           <a:prstGeom prst="rect">
             <a:avLst/>
@@ -4406,30 +4807,1212 @@
                 <a:spcPts val="0"/>
               </a:spcBef>
               <a:spcAft>
-                <a:spcPts val="0"/>
+                <a:spcPts val="400"/>
               </a:spcAft>
             </a:pPr>
             <a:r>
+              <a:rPr sz="1200" b="0" i="0">
+                <a:solidFill>
+                  <a:srgbClr val="555555"/>
+                </a:solidFill>
+                <a:latin typeface="Helvetica Neue"/>
+              </a:rPr>
+              <a:t>—  AI writes to a single type system with enforced invariants</a:t>
+            </a:r>
+          </a:p>
+          <a:p>
+            <a:pPr algn="l">
+              <a:spcBef>
+                <a:spcPts val="0"/>
+              </a:spcBef>
+              <a:spcAft>
+                <a:spcPts val="400"/>
+              </a:spcAft>
+            </a:pPr>
+            <a:r>
+              <a:rPr sz="1200" b="0" i="0">
+                <a:solidFill>
+                  <a:srgbClr val="555555"/>
+                </a:solidFill>
+                <a:latin typeface="Helvetica Neue"/>
+              </a:rPr>
+              <a:t>—  Sealed interfaces make entire vulnerability classes unrepresentable</a:t>
+            </a:r>
+          </a:p>
+          <a:p>
+            <a:pPr algn="l">
+              <a:spcBef>
+                <a:spcPts val="0"/>
+              </a:spcBef>
+              <a:spcAft>
+                <a:spcPts val="400"/>
+              </a:spcAft>
+            </a:pPr>
+            <a:r>
+              <a:rPr sz="1200" b="0" i="0">
+                <a:solidFill>
+                  <a:srgbClr val="555555"/>
+                </a:solidFill>
+                <a:latin typeface="Helvetica Neue"/>
+              </a:rPr>
+              <a:t>—  Agents work at the abstraction level, not the language level</a:t>
+            </a:r>
+          </a:p>
+          <a:p>
+            <a:pPr algn="l">
+              <a:spcBef>
+                <a:spcPts val="0"/>
+              </a:spcBef>
+              <a:spcAft>
+                <a:spcPts val="400"/>
+              </a:spcAft>
+            </a:pPr>
+            <a:r>
+              <a:rPr sz="1200" b="0" i="0">
+                <a:solidFill>
+                  <a:srgbClr val="555555"/>
+                </a:solidFill>
+                <a:latin typeface="Helvetica Neue"/>
+              </a:rPr>
+              <a:t>—  Review burden is constant: 1 source, regardless of target count</a:t>
+            </a:r>
+          </a:p>
+          <a:p>
+            <a:pPr algn="l">
+              <a:spcBef>
+                <a:spcPts val="0"/>
+              </a:spcBef>
+              <a:spcAft>
+                <a:spcPts val="400"/>
+              </a:spcAft>
+            </a:pPr>
+            <a:r>
+              <a:rPr sz="1200" b="0" i="0">
+                <a:solidFill>
+                  <a:srgbClr val="555555"/>
+                </a:solidFill>
+                <a:latin typeface="Helvetica Neue"/>
+              </a:rPr>
+              <a:t>—  Adding a 7th backend target requires zero security re-audit</a:t>
+            </a:r>
+          </a:p>
+        </p:txBody>
+      </p:sp>
+      <p:sp>
+        <p:nvSpPr>
+          <p:cNvPr id="11" name="TextBox 10"/>
+          <p:cNvSpPr txBox="1"/>
+          <p:nvPr/>
+        </p:nvSpPr>
+        <p:spPr>
+          <a:xfrm>
+            <a:off x="731520" y="5486400"/>
+            <a:ext cx="10728655" cy="914400"/>
+          </a:xfrm>
+          <a:prstGeom prst="rect">
+            <a:avLst/>
+          </a:prstGeom>
+          <a:noFill/>
+        </p:spPr>
+        <p:txBody>
+          <a:bodyPr wrap="square">
+            <a:spAutoFit/>
+          </a:bodyPr>
+          <a:lstStyle/>
+          <a:p>
+            <a:pPr algn="l">
+              <a:spcBef>
+                <a:spcPts val="0"/>
+              </a:spcBef>
+              <a:spcAft>
+                <a:spcPts val="0"/>
+              </a:spcAft>
+            </a:pPr>
+            <a:r>
+              <a:rPr sz="1800" b="0" i="0">
+                <a:solidFill>
+                  <a:srgbClr val="555555"/>
+                </a:solidFill>
+                <a:latin typeface="Helvetica Neue"/>
+              </a:rPr>
+              <a:t/>
+            </a:r>
+            <a:r>
+              <a:rPr sz="1600" b="0" i="0">
+                <a:solidFill>
+                  <a:srgbClr val="555555"/>
+                </a:solidFill>
+                <a:latin typeface="Helvetica Neue"/>
+              </a:rPr>
+              <a:t>Temper does not make AI smarter. It makes AI's mistakes </a:t>
+            </a:r>
+            <a:r>
+              <a:rPr sz="1600" b="1" i="0">
+                <a:solidFill>
+                  <a:srgbClr val="000000"/>
+                </a:solidFill>
+                <a:latin typeface="Helvetica Neue"/>
+              </a:rPr>
+              <a:t>structurally harmless</a:t>
+            </a:r>
+            <a:r>
+              <a:rPr sz="1600" b="0" i="0">
+                <a:solidFill>
+                  <a:srgbClr val="555555"/>
+                </a:solidFill>
+                <a:latin typeface="Helvetica Neue"/>
+              </a:rPr>
+              <a:t>.</a:t>
+            </a:r>
+          </a:p>
+        </p:txBody>
+      </p:sp>
+    </p:spTree>
+  </p:cSld>
+  <p:clrMapOvr>
+    <a:masterClrMapping/>
+  </p:clrMapOvr>
+</p:sld>
+</file>
+
+<file path=ppt/slides/slide12.xml><?xml version="1.0" encoding="utf-8"?>
+<p:sld xmlns:a="http://schemas.openxmlformats.org/drawingml/2006/main" xmlns:p="http://schemas.openxmlformats.org/presentationml/2006/main" xmlns:r="http://schemas.openxmlformats.org/officeDocument/2006/relationships">
+  <p:cSld>
+    <p:spTree>
+      <p:nvGrpSpPr>
+        <p:cNvPr id="1" name=""/>
+        <p:cNvGrpSpPr/>
+        <p:nvPr/>
+      </p:nvGrpSpPr>
+      <p:grpSpPr/>
+      <p:sp>
+        <p:nvSpPr>
+          <p:cNvPr id="2" name="TextBox 1"/>
+          <p:cNvSpPr txBox="1"/>
+          <p:nvPr/>
+        </p:nvSpPr>
+        <p:spPr>
+          <a:xfrm>
+            <a:off x="731520" y="457200"/>
+            <a:ext cx="10728655" cy="457200"/>
+          </a:xfrm>
+          <a:prstGeom prst="rect">
+            <a:avLst/>
+          </a:prstGeom>
+          <a:noFill/>
+        </p:spPr>
+        <p:txBody>
+          <a:bodyPr wrap="square">
+            <a:spAutoFit/>
+          </a:bodyPr>
+          <a:lstStyle/>
+          <a:p>
+            <a:pPr algn="l">
+              <a:spcBef>
+                <a:spcPts val="0"/>
+              </a:spcBef>
+              <a:spcAft>
+                <a:spcPts val="0"/>
+              </a:spcAft>
+            </a:pPr>
+            <a:r>
               <a:rPr sz="1300" b="0" i="0">
                 <a:solidFill>
+                  <a:srgbClr val="999999"/>
+                </a:solidFill>
+                <a:latin typeface="Helvetica Neue"/>
+              </a:rPr>
+              <a:t>AI + CODE REVIEW</a:t>
+            </a:r>
+          </a:p>
+        </p:txBody>
+      </p:sp>
+      <p:sp>
+        <p:nvSpPr>
+          <p:cNvPr id="3" name="TextBox 2"/>
+          <p:cNvSpPr txBox="1"/>
+          <p:nvPr/>
+        </p:nvSpPr>
+        <p:spPr>
+          <a:xfrm>
+            <a:off x="731520" y="822960"/>
+            <a:ext cx="10728655" cy="731520"/>
+          </a:xfrm>
+          <a:prstGeom prst="rect">
+            <a:avLst/>
+          </a:prstGeom>
+          <a:noFill/>
+        </p:spPr>
+        <p:txBody>
+          <a:bodyPr wrap="square">
+            <a:spAutoFit/>
+          </a:bodyPr>
+          <a:lstStyle/>
+          <a:p>
+            <a:pPr algn="l">
+              <a:spcBef>
+                <a:spcPts val="0"/>
+              </a:spcBef>
+              <a:spcAft>
+                <a:spcPts val="0"/>
+              </a:spcAft>
+            </a:pPr>
+            <a:r>
+              <a:rPr sz="3600" b="1" i="0">
+                <a:solidFill>
+                  <a:srgbClr val="111111"/>
+                </a:solidFill>
+                <a:latin typeface="Helvetica Neue"/>
+              </a:rPr>
+              <a:t>Review once, ship to every platform</a:t>
+            </a:r>
+          </a:p>
+        </p:txBody>
+      </p:sp>
+      <p:sp>
+        <p:nvSpPr>
+          <p:cNvPr id="4" name="TextBox 3"/>
+          <p:cNvSpPr txBox="1"/>
+          <p:nvPr/>
+        </p:nvSpPr>
+        <p:spPr>
+          <a:xfrm>
+            <a:off x="731520" y="1645920"/>
+            <a:ext cx="10728655" cy="914400"/>
+          </a:xfrm>
+          <a:prstGeom prst="rect">
+            <a:avLst/>
+          </a:prstGeom>
+          <a:noFill/>
+        </p:spPr>
+        <p:txBody>
+          <a:bodyPr wrap="square">
+            <a:spAutoFit/>
+          </a:bodyPr>
+          <a:lstStyle/>
+          <a:p>
+            <a:pPr algn="l">
+              <a:spcBef>
+                <a:spcPts val="0"/>
+              </a:spcBef>
+              <a:spcAft>
+                <a:spcPts val="0"/>
+              </a:spcAft>
+            </a:pPr>
+            <a:r>
+              <a:rPr sz="1600" b="0" i="0">
+                <a:solidFill>
                   <a:srgbClr val="555555"/>
                 </a:solidFill>
                 <a:latin typeface="Helvetica Neue"/>
               </a:rPr>
-              <a:t>Crypto wrappers, input validators, token parsers — the code that must be correct everywhere gets one audit, not twelve.</a:t>
-            </a:r>
-          </a:p>
-        </p:txBody>
-      </p:sp>
-      <p:sp>
-        <p:nvSpPr>
-          <p:cNvPr id="10" name="Rectangle 9"/>
+              <a:t>The bottleneck in AI-driven development is not code generation. It is code review. Temper compresses the review surface.</a:t>
+            </a:r>
+          </a:p>
+        </p:txBody>
+      </p:sp>
+      <p:sp>
+        <p:nvSpPr>
+          <p:cNvPr id="5" name="TextBox 4"/>
+          <p:cNvSpPr txBox="1"/>
+          <p:nvPr/>
+        </p:nvSpPr>
+        <p:spPr>
+          <a:xfrm>
+            <a:off x="1828800" y="2377440"/>
+            <a:ext cx="3200400" cy="1280160"/>
+          </a:xfrm>
+          <a:prstGeom prst="rect">
+            <a:avLst/>
+          </a:prstGeom>
+          <a:noFill/>
+        </p:spPr>
+        <p:txBody>
+          <a:bodyPr wrap="square">
+            <a:spAutoFit/>
+          </a:bodyPr>
+          <a:lstStyle/>
+          <a:p>
+            <a:pPr algn="ctr">
+              <a:spcBef>
+                <a:spcPts val="0"/>
+              </a:spcBef>
+              <a:spcAft>
+                <a:spcPts val="0"/>
+              </a:spcAft>
+            </a:pPr>
+            <a:r>
+              <a:rPr sz="6000" b="1" i="0">
+                <a:solidFill>
+                  <a:srgbClr val="000000"/>
+                </a:solidFill>
+                <a:latin typeface="Helvetica Neue"/>
+              </a:rPr>
+              <a:t>12×</a:t>
+            </a:r>
+          </a:p>
+          <a:p>
+            <a:pPr algn="ctr">
+              <a:spcBef>
+                <a:spcPts val="400"/>
+              </a:spcBef>
+              <a:spcAft>
+                <a:spcPts val="0"/>
+              </a:spcAft>
+            </a:pPr>
+            <a:r>
+              <a:rPr sz="1200" b="0" i="0">
+                <a:solidFill>
+                  <a:srgbClr val="999999"/>
+                </a:solidFill>
+                <a:latin typeface="Helvetica Neue"/>
+              </a:rPr>
+              <a:t>review burden today
+(one per language)</a:t>
+            </a:r>
+          </a:p>
+        </p:txBody>
+      </p:sp>
+      <p:sp>
+        <p:nvSpPr>
+          <p:cNvPr id="6" name="TextBox 5"/>
+          <p:cNvSpPr txBox="1"/>
+          <p:nvPr/>
+        </p:nvSpPr>
+        <p:spPr>
+          <a:xfrm>
+            <a:off x="5303520" y="2560320"/>
+            <a:ext cx="1371600" cy="548640"/>
+          </a:xfrm>
+          <a:prstGeom prst="rect">
+            <a:avLst/>
+          </a:prstGeom>
+          <a:noFill/>
+        </p:spPr>
+        <p:txBody>
+          <a:bodyPr wrap="square">
+            <a:spAutoFit/>
+          </a:bodyPr>
+          <a:lstStyle/>
+          <a:p>
+            <a:pPr algn="ctr">
+              <a:spcBef>
+                <a:spcPts val="0"/>
+              </a:spcBef>
+              <a:spcAft>
+                <a:spcPts val="0"/>
+              </a:spcAft>
+            </a:pPr>
+            <a:r>
+              <a:rPr sz="3600" b="0" i="0">
+                <a:solidFill>
+                  <a:srgbClr val="DDDDDD"/>
+                </a:solidFill>
+                <a:latin typeface="Helvetica Neue"/>
+              </a:rPr>
+              <a:t>→</a:t>
+            </a:r>
+          </a:p>
+        </p:txBody>
+      </p:sp>
+      <p:sp>
+        <p:nvSpPr>
+          <p:cNvPr id="7" name="TextBox 6"/>
+          <p:cNvSpPr txBox="1"/>
+          <p:nvPr/>
+        </p:nvSpPr>
+        <p:spPr>
+          <a:xfrm>
+            <a:off x="7132320" y="2377440"/>
+            <a:ext cx="3200400" cy="1280160"/>
+          </a:xfrm>
+          <a:prstGeom prst="rect">
+            <a:avLst/>
+          </a:prstGeom>
+          <a:noFill/>
+        </p:spPr>
+        <p:txBody>
+          <a:bodyPr wrap="square">
+            <a:spAutoFit/>
+          </a:bodyPr>
+          <a:lstStyle/>
+          <a:p>
+            <a:pPr algn="ctr">
+              <a:spcBef>
+                <a:spcPts val="0"/>
+              </a:spcBef>
+              <a:spcAft>
+                <a:spcPts val="0"/>
+              </a:spcAft>
+            </a:pPr>
+            <a:r>
+              <a:rPr sz="6000" b="1" i="0">
+                <a:solidFill>
+                  <a:srgbClr val="000000"/>
+                </a:solidFill>
+                <a:latin typeface="Helvetica Neue"/>
+              </a:rPr>
+              <a:t>1×</a:t>
+            </a:r>
+          </a:p>
+          <a:p>
+            <a:pPr algn="ctr">
+              <a:spcBef>
+                <a:spcPts val="400"/>
+              </a:spcBef>
+              <a:spcAft>
+                <a:spcPts val="0"/>
+              </a:spcAft>
+            </a:pPr>
+            <a:r>
+              <a:rPr sz="1200" b="0" i="0">
+                <a:solidFill>
+                  <a:srgbClr val="999999"/>
+                </a:solidFill>
+                <a:latin typeface="Helvetica Neue"/>
+              </a:rPr>
+              <a:t>review burden with Temper
+(one source of truth)</a:t>
+            </a:r>
+          </a:p>
+        </p:txBody>
+      </p:sp>
+      <p:sp>
+        <p:nvSpPr>
+          <p:cNvPr id="8" name="TextBox 7"/>
+          <p:cNvSpPr txBox="1"/>
+          <p:nvPr/>
+        </p:nvSpPr>
+        <p:spPr>
+          <a:xfrm>
+            <a:off x="914400" y="4206240"/>
+            <a:ext cx="10545775" cy="1371600"/>
+          </a:xfrm>
+          <a:prstGeom prst="rect">
+            <a:avLst/>
+          </a:prstGeom>
+          <a:noFill/>
+        </p:spPr>
+        <p:txBody>
+          <a:bodyPr wrap="square">
+            <a:spAutoFit/>
+          </a:bodyPr>
+          <a:lstStyle/>
+          <a:p>
+            <a:pPr algn="l">
+              <a:spcBef>
+                <a:spcPts val="0"/>
+              </a:spcBef>
+              <a:spcAft>
+                <a:spcPts val="400"/>
+              </a:spcAft>
+            </a:pPr>
+            <a:r>
+              <a:rPr sz="1400" b="0" i="0">
+                <a:solidFill>
+                  <a:srgbClr val="555555"/>
+                </a:solidFill>
+                <a:latin typeface="Helvetica Neue"/>
+              </a:rPr>
+              <a:t>—  AI generates a Temper library — human reviews one codebase</a:t>
+            </a:r>
+          </a:p>
+          <a:p>
+            <a:pPr algn="l">
+              <a:spcBef>
+                <a:spcPts val="0"/>
+              </a:spcBef>
+              <a:spcAft>
+                <a:spcPts val="400"/>
+              </a:spcAft>
+            </a:pPr>
+            <a:r>
+              <a:rPr sz="1400" b="0" i="0">
+                <a:solidFill>
+                  <a:srgbClr val="555555"/>
+                </a:solidFill>
+                <a:latin typeface="Helvetica Neue"/>
+              </a:rPr>
+              <a:t>—  Approved code compiles to all targets with identical security properties</a:t>
+            </a:r>
+          </a:p>
+          <a:p>
+            <a:pPr algn="l">
+              <a:spcBef>
+                <a:spcPts val="0"/>
+              </a:spcBef>
+              <a:spcAft>
+                <a:spcPts val="400"/>
+              </a:spcAft>
+            </a:pPr>
+            <a:r>
+              <a:rPr sz="1400" b="0" i="0">
+                <a:solidFill>
+                  <a:srgbClr val="555555"/>
+                </a:solidFill>
+                <a:latin typeface="Helvetica Neue"/>
+              </a:rPr>
+              <a:t>—  No per-language security specialists needed for generated output</a:t>
+            </a:r>
+          </a:p>
+          <a:p>
+            <a:pPr algn="l">
+              <a:spcBef>
+                <a:spcPts val="0"/>
+              </a:spcBef>
+              <a:spcAft>
+                <a:spcPts val="400"/>
+              </a:spcAft>
+            </a:pPr>
+            <a:r>
+              <a:rPr sz="1400" b="0" i="0">
+                <a:solidFill>
+                  <a:srgbClr val="555555"/>
+                </a:solidFill>
+                <a:latin typeface="Helvetica Neue"/>
+              </a:rPr>
+              <a:t>—  Audit trail is one git history, not twelve</a:t>
+            </a:r>
+          </a:p>
+        </p:txBody>
+      </p:sp>
+      <p:sp>
+        <p:nvSpPr>
+          <p:cNvPr id="9" name="TextBox 8"/>
+          <p:cNvSpPr txBox="1"/>
+          <p:nvPr/>
+        </p:nvSpPr>
+        <p:spPr>
+          <a:xfrm>
+            <a:off x="731520" y="5486400"/>
+            <a:ext cx="10728655" cy="914400"/>
+          </a:xfrm>
+          <a:prstGeom prst="rect">
+            <a:avLst/>
+          </a:prstGeom>
+          <a:noFill/>
+        </p:spPr>
+        <p:txBody>
+          <a:bodyPr wrap="square">
+            <a:spAutoFit/>
+          </a:bodyPr>
+          <a:lstStyle/>
+          <a:p>
+            <a:pPr algn="l">
+              <a:spcBef>
+                <a:spcPts val="0"/>
+              </a:spcBef>
+              <a:spcAft>
+                <a:spcPts val="0"/>
+              </a:spcAft>
+            </a:pPr>
+            <a:r>
+              <a:rPr sz="1800" b="0" i="0">
+                <a:solidFill>
+                  <a:srgbClr val="555555"/>
+                </a:solidFill>
+                <a:latin typeface="Helvetica Neue"/>
+              </a:rPr>
+              <a:t/>
+            </a:r>
+            <a:r>
+              <a:rPr sz="1600" b="0" i="0">
+                <a:solidFill>
+                  <a:srgbClr val="555555"/>
+                </a:solidFill>
+                <a:latin typeface="Helvetica Neue"/>
+              </a:rPr>
+              <a:t>When your organization ships SDKs in 12 languages, the difference between reviewing 12 AI-generated codebases and reviewing 1 is the difference between </a:t>
+            </a:r>
+            <a:r>
+              <a:rPr sz="1600" b="1" i="0">
+                <a:solidFill>
+                  <a:srgbClr val="000000"/>
+                </a:solidFill>
+                <a:latin typeface="Helvetica Neue"/>
+              </a:rPr>
+              <a:t>possible and impossible</a:t>
+            </a:r>
+            <a:r>
+              <a:rPr sz="1600" b="0" i="0">
+                <a:solidFill>
+                  <a:srgbClr val="555555"/>
+                </a:solidFill>
+                <a:latin typeface="Helvetica Neue"/>
+              </a:rPr>
+              <a:t>.</a:t>
+            </a:r>
+          </a:p>
+        </p:txBody>
+      </p:sp>
+    </p:spTree>
+  </p:cSld>
+  <p:clrMapOvr>
+    <a:masterClrMapping/>
+  </p:clrMapOvr>
+</p:sld>
+</file>
+
+<file path=ppt/slides/slide13.xml><?xml version="1.0" encoding="utf-8"?>
+<p:sld xmlns:a="http://schemas.openxmlformats.org/drawingml/2006/main" xmlns:p="http://schemas.openxmlformats.org/presentationml/2006/main" xmlns:r="http://schemas.openxmlformats.org/officeDocument/2006/relationships">
+  <p:cSld>
+    <p:spTree>
+      <p:nvGrpSpPr>
+        <p:cNvPr id="1" name=""/>
+        <p:cNvGrpSpPr/>
+        <p:nvPr/>
+      </p:nvGrpSpPr>
+      <p:grpSpPr/>
+      <p:sp>
+        <p:nvSpPr>
+          <p:cNvPr id="2" name="TextBox 1"/>
+          <p:cNvSpPr txBox="1"/>
+          <p:nvPr/>
+        </p:nvSpPr>
+        <p:spPr>
+          <a:xfrm>
+            <a:off x="731520" y="457200"/>
+            <a:ext cx="10728655" cy="457200"/>
+          </a:xfrm>
+          <a:prstGeom prst="rect">
+            <a:avLst/>
+          </a:prstGeom>
+          <a:noFill/>
+        </p:spPr>
+        <p:txBody>
+          <a:bodyPr wrap="square">
+            <a:spAutoFit/>
+          </a:bodyPr>
+          <a:lstStyle/>
+          <a:p>
+            <a:pPr algn="l">
+              <a:spcBef>
+                <a:spcPts val="0"/>
+              </a:spcBef>
+              <a:spcAft>
+                <a:spcPts val="0"/>
+              </a:spcAft>
+            </a:pPr>
+            <a:r>
+              <a:rPr sz="1300" b="0" i="0">
+                <a:solidFill>
+                  <a:srgbClr val="999999"/>
+                </a:solidFill>
+                <a:latin typeface="Helvetica Neue"/>
+              </a:rPr>
+              <a:t>AT SCALE</a:t>
+            </a:r>
+          </a:p>
+        </p:txBody>
+      </p:sp>
+      <p:sp>
+        <p:nvSpPr>
+          <p:cNvPr id="3" name="TextBox 2"/>
+          <p:cNvSpPr txBox="1"/>
+          <p:nvPr/>
+        </p:nvSpPr>
+        <p:spPr>
+          <a:xfrm>
+            <a:off x="731520" y="822960"/>
+            <a:ext cx="10728655" cy="731520"/>
+          </a:xfrm>
+          <a:prstGeom prst="rect">
+            <a:avLst/>
+          </a:prstGeom>
+          <a:noFill/>
+        </p:spPr>
+        <p:txBody>
+          <a:bodyPr wrap="square">
+            <a:spAutoFit/>
+          </a:bodyPr>
+          <a:lstStyle/>
+          <a:p>
+            <a:pPr algn="l">
+              <a:spcBef>
+                <a:spcPts val="0"/>
+              </a:spcBef>
+              <a:spcAft>
+                <a:spcPts val="0"/>
+              </a:spcAft>
+            </a:pPr>
+            <a:r>
+              <a:rPr sz="3600" b="1" i="0">
+                <a:solidFill>
+                  <a:srgbClr val="111111"/>
+                </a:solidFill>
+                <a:latin typeface="Helvetica Neue"/>
+              </a:rPr>
+              <a:t>What if SDK security was a single source of truth?</a:t>
+            </a:r>
+          </a:p>
+        </p:txBody>
+      </p:sp>
+      <p:sp>
+        <p:nvSpPr>
+          <p:cNvPr id="4" name="TextBox 3"/>
+          <p:cNvSpPr txBox="1"/>
+          <p:nvPr/>
+        </p:nvSpPr>
+        <p:spPr>
+          <a:xfrm>
+            <a:off x="1828800" y="2011680"/>
+            <a:ext cx="3200400" cy="1280160"/>
+          </a:xfrm>
+          <a:prstGeom prst="rect">
+            <a:avLst/>
+          </a:prstGeom>
+          <a:noFill/>
+        </p:spPr>
+        <p:txBody>
+          <a:bodyPr wrap="square">
+            <a:spAutoFit/>
+          </a:bodyPr>
+          <a:lstStyle/>
+          <a:p>
+            <a:pPr algn="ctr">
+              <a:spcBef>
+                <a:spcPts val="0"/>
+              </a:spcBef>
+              <a:spcAft>
+                <a:spcPts val="0"/>
+              </a:spcAft>
+            </a:pPr>
+            <a:r>
+              <a:rPr sz="6000" b="1" i="0">
+                <a:solidFill>
+                  <a:srgbClr val="000000"/>
+                </a:solidFill>
+                <a:latin typeface="Helvetica Neue"/>
+              </a:rPr>
+              <a:t>3,600</a:t>
+            </a:r>
+          </a:p>
+          <a:p>
+            <a:pPr algn="ctr">
+              <a:spcBef>
+                <a:spcPts val="400"/>
+              </a:spcBef>
+              <a:spcAft>
+                <a:spcPts val="0"/>
+              </a:spcAft>
+            </a:pPr>
+            <a:r>
+              <a:rPr sz="1200" b="0" i="0">
+                <a:solidFill>
+                  <a:srgbClr val="999999"/>
+                </a:solidFill>
+                <a:latin typeface="Helvetica Neue"/>
+              </a:rPr>
+              <a:t>libraries to patch today</a:t>
+            </a:r>
+          </a:p>
+        </p:txBody>
+      </p:sp>
+      <p:sp>
+        <p:nvSpPr>
+          <p:cNvPr id="5" name="TextBox 4"/>
+          <p:cNvSpPr txBox="1"/>
+          <p:nvPr/>
+        </p:nvSpPr>
+        <p:spPr>
+          <a:xfrm>
+            <a:off x="5303520" y="2194560"/>
+            <a:ext cx="1371600" cy="548640"/>
+          </a:xfrm>
+          <a:prstGeom prst="rect">
+            <a:avLst/>
+          </a:prstGeom>
+          <a:noFill/>
+        </p:spPr>
+        <p:txBody>
+          <a:bodyPr wrap="square">
+            <a:spAutoFit/>
+          </a:bodyPr>
+          <a:lstStyle/>
+          <a:p>
+            <a:pPr algn="ctr">
+              <a:spcBef>
+                <a:spcPts val="0"/>
+              </a:spcBef>
+              <a:spcAft>
+                <a:spcPts val="0"/>
+              </a:spcAft>
+            </a:pPr>
+            <a:r>
+              <a:rPr sz="3600" b="0" i="0">
+                <a:solidFill>
+                  <a:srgbClr val="DDDDDD"/>
+                </a:solidFill>
+                <a:latin typeface="Helvetica Neue"/>
+              </a:rPr>
+              <a:t>→</a:t>
+            </a:r>
+          </a:p>
+        </p:txBody>
+      </p:sp>
+      <p:sp>
+        <p:nvSpPr>
+          <p:cNvPr id="6" name="TextBox 5"/>
+          <p:cNvSpPr txBox="1"/>
+          <p:nvPr/>
+        </p:nvSpPr>
+        <p:spPr>
+          <a:xfrm>
+            <a:off x="7132320" y="2011680"/>
+            <a:ext cx="3200400" cy="1280160"/>
+          </a:xfrm>
+          <a:prstGeom prst="rect">
+            <a:avLst/>
+          </a:prstGeom>
+          <a:noFill/>
+        </p:spPr>
+        <p:txBody>
+          <a:bodyPr wrap="square">
+            <a:spAutoFit/>
+          </a:bodyPr>
+          <a:lstStyle/>
+          <a:p>
+            <a:pPr algn="ctr">
+              <a:spcBef>
+                <a:spcPts val="0"/>
+              </a:spcBef>
+              <a:spcAft>
+                <a:spcPts val="0"/>
+              </a:spcAft>
+            </a:pPr>
+            <a:r>
+              <a:rPr sz="6000" b="1" i="0">
+                <a:solidFill>
+                  <a:srgbClr val="000000"/>
+                </a:solidFill>
+                <a:latin typeface="Helvetica Neue"/>
+              </a:rPr>
+              <a:t>300</a:t>
+            </a:r>
+          </a:p>
+          <a:p>
+            <a:pPr algn="ctr">
+              <a:spcBef>
+                <a:spcPts val="400"/>
+              </a:spcBef>
+              <a:spcAft>
+                <a:spcPts val="0"/>
+              </a:spcAft>
+            </a:pPr>
+            <a:r>
+              <a:rPr sz="1200" b="0" i="0">
+                <a:solidFill>
+                  <a:srgbClr val="999999"/>
+                </a:solidFill>
+                <a:latin typeface="Helvetica Neue"/>
+              </a:rPr>
+              <a:t>Temper sources to maintain</a:t>
+            </a:r>
+          </a:p>
+        </p:txBody>
+      </p:sp>
+      <p:sp>
+        <p:nvSpPr>
+          <p:cNvPr id="7" name="TextBox 6"/>
+          <p:cNvSpPr txBox="1"/>
+          <p:nvPr/>
+        </p:nvSpPr>
+        <p:spPr>
+          <a:xfrm>
+            <a:off x="731520" y="3657600"/>
+            <a:ext cx="10728655" cy="914400"/>
+          </a:xfrm>
+          <a:prstGeom prst="rect">
+            <a:avLst/>
+          </a:prstGeom>
+          <a:noFill/>
+        </p:spPr>
+        <p:txBody>
+          <a:bodyPr wrap="square">
+            <a:spAutoFit/>
+          </a:bodyPr>
+          <a:lstStyle/>
+          <a:p>
+            <a:pPr algn="l">
+              <a:spcBef>
+                <a:spcPts val="0"/>
+              </a:spcBef>
+              <a:spcAft>
+                <a:spcPts val="0"/>
+              </a:spcAft>
+            </a:pPr>
+            <a:r>
+              <a:rPr sz="1600" b="0" i="0">
+                <a:solidFill>
+                  <a:srgbClr val="555555"/>
+                </a:solidFill>
+                <a:latin typeface="Helvetica Neue"/>
+              </a:rPr>
+              <a:t>AWS manages 300+ services across 12 languages. A single vulnerability requires coordinated patches across:</a:t>
+            </a:r>
+          </a:p>
+        </p:txBody>
+      </p:sp>
+      <p:sp>
+        <p:nvSpPr>
+          <p:cNvPr id="8" name="TextBox 7"/>
+          <p:cNvSpPr txBox="1"/>
+          <p:nvPr/>
+        </p:nvSpPr>
+        <p:spPr>
+          <a:xfrm>
+            <a:off x="914400" y="4297680"/>
+            <a:ext cx="10545775" cy="1371600"/>
+          </a:xfrm>
+          <a:prstGeom prst="rect">
+            <a:avLst/>
+          </a:prstGeom>
+          <a:noFill/>
+        </p:spPr>
+        <p:txBody>
+          <a:bodyPr wrap="square">
+            <a:spAutoFit/>
+          </a:bodyPr>
+          <a:lstStyle/>
+          <a:p>
+            <a:pPr algn="l">
+              <a:spcBef>
+                <a:spcPts val="0"/>
+              </a:spcBef>
+              <a:spcAft>
+                <a:spcPts val="400"/>
+              </a:spcAft>
+            </a:pPr>
+            <a:r>
+              <a:rPr sz="1400" b="0" i="0">
+                <a:solidFill>
+                  <a:srgbClr val="555555"/>
+                </a:solidFill>
+                <a:latin typeface="Helvetica Neue"/>
+              </a:rPr>
+              <a:t>—  12 SDK repositories with independent release cycles</a:t>
+            </a:r>
+          </a:p>
+          <a:p>
+            <a:pPr algn="l">
+              <a:spcBef>
+                <a:spcPts val="0"/>
+              </a:spcBef>
+              <a:spcAft>
+                <a:spcPts val="400"/>
+              </a:spcAft>
+            </a:pPr>
+            <a:r>
+              <a:rPr sz="1400" b="0" i="0">
+                <a:solidFill>
+                  <a:srgbClr val="555555"/>
+                </a:solidFill>
+                <a:latin typeface="Helvetica Neue"/>
+              </a:rPr>
+              <a:t>—  8+ package registries (npm, PyPI, Maven, NuGet, crates.io, RubyGems, Packagist, Go proxy)</a:t>
+            </a:r>
+          </a:p>
+          <a:p>
+            <a:pPr algn="l">
+              <a:spcBef>
+                <a:spcPts val="0"/>
+              </a:spcBef>
+              <a:spcAft>
+                <a:spcPts val="400"/>
+              </a:spcAft>
+            </a:pPr>
+            <a:r>
+              <a:rPr sz="1400" b="0" i="0">
+                <a:solidFill>
+                  <a:srgbClr val="555555"/>
+                </a:solidFill>
+                <a:latin typeface="Helvetica Neue"/>
+              </a:rPr>
+              <a:t>—  Daily releases that must be synchronized</a:t>
+            </a:r>
+          </a:p>
+        </p:txBody>
+      </p:sp>
+      <p:sp>
+        <p:nvSpPr>
+          <p:cNvPr id="9" name="TextBox 8"/>
+          <p:cNvSpPr txBox="1"/>
+          <p:nvPr/>
+        </p:nvSpPr>
+        <p:spPr>
+          <a:xfrm>
+            <a:off x="731520" y="5486400"/>
+            <a:ext cx="10728655" cy="914400"/>
+          </a:xfrm>
+          <a:prstGeom prst="rect">
+            <a:avLst/>
+          </a:prstGeom>
+          <a:noFill/>
+        </p:spPr>
+        <p:txBody>
+          <a:bodyPr wrap="square">
+            <a:spAutoFit/>
+          </a:bodyPr>
+          <a:lstStyle/>
+          <a:p>
+            <a:pPr algn="l">
+              <a:spcBef>
+                <a:spcPts val="0"/>
+              </a:spcBef>
+              <a:spcAft>
+                <a:spcPts val="0"/>
+              </a:spcAft>
+            </a:pPr>
+            <a:r>
+              <a:rPr sz="1800" b="0" i="0">
+                <a:solidFill>
+                  <a:srgbClr val="555555"/>
+                </a:solidFill>
+                <a:latin typeface="Helvetica Neue"/>
+              </a:rPr>
+              <a:t/>
+            </a:r>
+            <a:r>
+              <a:rPr sz="1600" b="0" i="0">
+                <a:solidFill>
+                  <a:srgbClr val="555555"/>
+                </a:solidFill>
+                <a:latin typeface="Helvetica Neue"/>
+              </a:rPr>
+              <a:t>With Temper, security logic lives in </a:t>
+            </a:r>
+            <a:r>
+              <a:rPr sz="1600" b="1" i="0">
+                <a:solidFill>
+                  <a:srgbClr val="000000"/>
+                </a:solidFill>
+                <a:latin typeface="Helvetica Neue"/>
+              </a:rPr>
+              <a:t>one place</a:t>
+            </a:r>
+            <a:r>
+              <a:rPr sz="1600" b="0" i="0">
+                <a:solidFill>
+                  <a:srgbClr val="555555"/>
+                </a:solidFill>
+                <a:latin typeface="Helvetica Neue"/>
+              </a:rPr>
+              <a:t>. A fix compiles to all targets in a single build. No coordination. No drift.</a:t>
+            </a:r>
+          </a:p>
+        </p:txBody>
+      </p:sp>
+    </p:spTree>
+  </p:cSld>
+  <p:clrMapOvr>
+    <a:masterClrMapping/>
+  </p:clrMapOvr>
+</p:sld>
+</file>
+
+<file path=ppt/slides/slide14.xml><?xml version="1.0" encoding="utf-8"?>
+<p:sld xmlns:a="http://schemas.openxmlformats.org/drawingml/2006/main" xmlns:p="http://schemas.openxmlformats.org/presentationml/2006/main" xmlns:r="http://schemas.openxmlformats.org/officeDocument/2006/relationships">
+  <p:cSld>
+    <p:spTree>
+      <p:nvGrpSpPr>
+        <p:cNvPr id="1" name=""/>
+        <p:cNvGrpSpPr/>
+        <p:nvPr/>
+      </p:nvGrpSpPr>
+      <p:grpSpPr/>
+      <p:sp>
+        <p:nvSpPr>
+          <p:cNvPr id="2" name="TextBox 1"/>
+          <p:cNvSpPr txBox="1"/>
+          <p:nvPr/>
+        </p:nvSpPr>
+        <p:spPr>
+          <a:xfrm>
+            <a:off x="731520" y="457200"/>
+            <a:ext cx="10728655" cy="457200"/>
+          </a:xfrm>
+          <a:prstGeom prst="rect">
+            <a:avLst/>
+          </a:prstGeom>
+          <a:noFill/>
+        </p:spPr>
+        <p:txBody>
+          <a:bodyPr wrap="square">
+            <a:spAutoFit/>
+          </a:bodyPr>
+          <a:lstStyle/>
+          <a:p>
+            <a:pPr algn="l">
+              <a:spcBef>
+                <a:spcPts val="0"/>
+              </a:spcBef>
+              <a:spcAft>
+                <a:spcPts val="0"/>
+              </a:spcAft>
+            </a:pPr>
+            <a:r>
+              <a:rPr sz="1300" b="0" i="0">
+                <a:solidFill>
+                  <a:srgbClr val="999999"/>
+                </a:solidFill>
+                <a:latin typeface="Helvetica Neue"/>
+              </a:rPr>
+              <a:t>BEYOND THIS DEMO</a:t>
+            </a:r>
+          </a:p>
+        </p:txBody>
+      </p:sp>
+      <p:sp>
+        <p:nvSpPr>
+          <p:cNvPr id="3" name="TextBox 2"/>
+          <p:cNvSpPr txBox="1"/>
+          <p:nvPr/>
+        </p:nvSpPr>
+        <p:spPr>
+          <a:xfrm>
+            <a:off x="731520" y="822960"/>
+            <a:ext cx="10728655" cy="731520"/>
+          </a:xfrm>
+          <a:prstGeom prst="rect">
+            <a:avLst/>
+          </a:prstGeom>
+          <a:noFill/>
+        </p:spPr>
+        <p:txBody>
+          <a:bodyPr wrap="square">
+            <a:spAutoFit/>
+          </a:bodyPr>
+          <a:lstStyle/>
+          <a:p>
+            <a:pPr algn="l">
+              <a:spcBef>
+                <a:spcPts val="0"/>
+              </a:spcBef>
+              <a:spcAft>
+                <a:spcPts val="0"/>
+              </a:spcAft>
+            </a:pPr>
+            <a:r>
+              <a:rPr sz="3600" b="1" i="0">
+                <a:solidFill>
+                  <a:srgbClr val="111111"/>
+                </a:solidFill>
+                <a:latin typeface="Helvetica Neue"/>
+              </a:rPr>
+              <a:t>Where Temper changes the game</a:t>
+            </a:r>
+          </a:p>
+        </p:txBody>
+      </p:sp>
+      <p:sp>
+        <p:nvSpPr>
+          <p:cNvPr id="4" name="Rectangle 3"/>
           <p:cNvSpPr/>
           <p:nvPr/>
         </p:nvSpPr>
         <p:spPr>
           <a:xfrm>
-            <a:off x="731520" y="3931920"/>
+            <a:off x="731520" y="1828800"/>
             <a:ext cx="5120640" cy="1828800"/>
           </a:xfrm>
           <a:prstGeom prst="rect">
@@ -4468,13 +6051,13 @@
       </p:sp>
       <p:sp>
         <p:nvSpPr>
-          <p:cNvPr id="11" name="TextBox 10"/>
+          <p:cNvPr id="5" name="TextBox 4"/>
           <p:cNvSpPr txBox="1"/>
           <p:nvPr/>
         </p:nvSpPr>
         <p:spPr>
           <a:xfrm>
-            <a:off x="960120" y="4114800"/>
+            <a:off x="960120" y="2011680"/>
             <a:ext cx="4663440" cy="365760"/>
           </a:xfrm>
           <a:prstGeom prst="rect">
@@ -4503,20 +6086,20 @@
                 </a:solidFill>
                 <a:latin typeface="Helvetica Neue"/>
               </a:rPr>
-              <a:t>Data Validation</a:t>
-            </a:r>
-          </a:p>
-        </p:txBody>
-      </p:sp>
-      <p:sp>
-        <p:nvSpPr>
-          <p:cNvPr id="12" name="TextBox 11"/>
+              <a:t>SDK Libraries</a:t>
+            </a:r>
+          </a:p>
+        </p:txBody>
+      </p:sp>
+      <p:sp>
+        <p:nvSpPr>
+          <p:cNvPr id="6" name="TextBox 5"/>
           <p:cNvSpPr txBox="1"/>
           <p:nvPr/>
         </p:nvSpPr>
         <p:spPr>
           <a:xfrm>
-            <a:off x="960120" y="4572000"/>
+            <a:off x="960120" y="2468880"/>
             <a:ext cx="4663440" cy="1097280"/>
           </a:xfrm>
           <a:prstGeom prst="rect">
@@ -4545,20 +6128,20 @@
                 </a:solidFill>
                 <a:latin typeface="Helvetica Neue"/>
               </a:rPr>
-              <a:t>Schema validators, sanitizers, format parsers — consistent behavior across frontend, backend, and systems languages.</a:t>
-            </a:r>
-          </a:p>
-        </p:txBody>
-      </p:sp>
-      <p:sp>
-        <p:nvSpPr>
-          <p:cNvPr id="13" name="Rectangle 12"/>
+              <a:t>API clients, serialization, auth flows, retry logic — write once, ship to every language your customers use.</a:t>
+            </a:r>
+          </a:p>
+        </p:txBody>
+      </p:sp>
+      <p:sp>
+        <p:nvSpPr>
+          <p:cNvPr id="7" name="Rectangle 6"/>
           <p:cNvSpPr/>
           <p:nvPr/>
         </p:nvSpPr>
         <p:spPr>
           <a:xfrm>
-            <a:off x="6400800" y="3931920"/>
+            <a:off x="6400800" y="1828800"/>
             <a:ext cx="5120640" cy="1828800"/>
           </a:xfrm>
           <a:prstGeom prst="rect">
@@ -4597,6 +6180,264 @@
       </p:sp>
       <p:sp>
         <p:nvSpPr>
+          <p:cNvPr id="8" name="TextBox 7"/>
+          <p:cNvSpPr txBox="1"/>
+          <p:nvPr/>
+        </p:nvSpPr>
+        <p:spPr>
+          <a:xfrm>
+            <a:off x="6629400" y="2011680"/>
+            <a:ext cx="4663440" cy="365760"/>
+          </a:xfrm>
+          <a:prstGeom prst="rect">
+            <a:avLst/>
+          </a:prstGeom>
+          <a:noFill/>
+        </p:spPr>
+        <p:txBody>
+          <a:bodyPr wrap="square">
+            <a:spAutoFit/>
+          </a:bodyPr>
+          <a:lstStyle/>
+          <a:p>
+            <a:pPr algn="l">
+              <a:spcBef>
+                <a:spcPts val="0"/>
+              </a:spcBef>
+              <a:spcAft>
+                <a:spcPts val="0"/>
+              </a:spcAft>
+            </a:pPr>
+            <a:r>
+              <a:rPr sz="1600" b="1" i="0">
+                <a:solidFill>
+                  <a:srgbClr val="111111"/>
+                </a:solidFill>
+                <a:latin typeface="Helvetica Neue"/>
+              </a:rPr>
+              <a:t>Security Primitives</a:t>
+            </a:r>
+          </a:p>
+        </p:txBody>
+      </p:sp>
+      <p:sp>
+        <p:nvSpPr>
+          <p:cNvPr id="9" name="TextBox 8"/>
+          <p:cNvSpPr txBox="1"/>
+          <p:nvPr/>
+        </p:nvSpPr>
+        <p:spPr>
+          <a:xfrm>
+            <a:off x="6629400" y="2468880"/>
+            <a:ext cx="4663440" cy="1097280"/>
+          </a:xfrm>
+          <a:prstGeom prst="rect">
+            <a:avLst/>
+          </a:prstGeom>
+          <a:noFill/>
+        </p:spPr>
+        <p:txBody>
+          <a:bodyPr wrap="square">
+            <a:spAutoFit/>
+          </a:bodyPr>
+          <a:lstStyle/>
+          <a:p>
+            <a:pPr algn="l">
+              <a:spcBef>
+                <a:spcPts val="0"/>
+              </a:spcBef>
+              <a:spcAft>
+                <a:spcPts val="0"/>
+              </a:spcAft>
+            </a:pPr>
+            <a:r>
+              <a:rPr sz="1300" b="0" i="0">
+                <a:solidFill>
+                  <a:srgbClr val="555555"/>
+                </a:solidFill>
+                <a:latin typeface="Helvetica Neue"/>
+              </a:rPr>
+              <a:t>Crypto wrappers, input validators, token parsers — the code that must be correct everywhere gets one audit, not twelve.</a:t>
+            </a:r>
+          </a:p>
+        </p:txBody>
+      </p:sp>
+      <p:sp>
+        <p:nvSpPr>
+          <p:cNvPr id="10" name="Rectangle 9"/>
+          <p:cNvSpPr/>
+          <p:nvPr/>
+        </p:nvSpPr>
+        <p:spPr>
+          <a:xfrm>
+            <a:off x="731520" y="3931920"/>
+            <a:ext cx="5120640" cy="1828800"/>
+          </a:xfrm>
+          <a:prstGeom prst="rect">
+            <a:avLst/>
+          </a:prstGeom>
+          <a:solidFill>
+            <a:srgbClr val="FFFFFF"/>
+          </a:solidFill>
+          <a:ln w="9525">
+            <a:solidFill>
+              <a:srgbClr val="DDDDDD"/>
+            </a:solidFill>
+          </a:ln>
+        </p:spPr>
+        <p:style>
+          <a:lnRef idx="1">
+            <a:schemeClr val="accent1"/>
+          </a:lnRef>
+          <a:fillRef idx="3">
+            <a:schemeClr val="accent1"/>
+          </a:fillRef>
+          <a:effectRef idx="2">
+            <a:schemeClr val="accent1"/>
+          </a:effectRef>
+          <a:fontRef idx="minor">
+            <a:schemeClr val="lt1"/>
+          </a:fontRef>
+        </p:style>
+        <p:txBody>
+          <a:bodyPr rtlCol="0" anchor="ctr"/>
+          <a:lstStyle/>
+          <a:p>
+            <a:pPr algn="ctr"/>
+          </a:p>
+        </p:txBody>
+      </p:sp>
+      <p:sp>
+        <p:nvSpPr>
+          <p:cNvPr id="11" name="TextBox 10"/>
+          <p:cNvSpPr txBox="1"/>
+          <p:nvPr/>
+        </p:nvSpPr>
+        <p:spPr>
+          <a:xfrm>
+            <a:off x="960120" y="4114800"/>
+            <a:ext cx="4663440" cy="365760"/>
+          </a:xfrm>
+          <a:prstGeom prst="rect">
+            <a:avLst/>
+          </a:prstGeom>
+          <a:noFill/>
+        </p:spPr>
+        <p:txBody>
+          <a:bodyPr wrap="square">
+            <a:spAutoFit/>
+          </a:bodyPr>
+          <a:lstStyle/>
+          <a:p>
+            <a:pPr algn="l">
+              <a:spcBef>
+                <a:spcPts val="0"/>
+              </a:spcBef>
+              <a:spcAft>
+                <a:spcPts val="0"/>
+              </a:spcAft>
+            </a:pPr>
+            <a:r>
+              <a:rPr sz="1600" b="1" i="0">
+                <a:solidFill>
+                  <a:srgbClr val="111111"/>
+                </a:solidFill>
+                <a:latin typeface="Helvetica Neue"/>
+              </a:rPr>
+              <a:t>Data Validation</a:t>
+            </a:r>
+          </a:p>
+        </p:txBody>
+      </p:sp>
+      <p:sp>
+        <p:nvSpPr>
+          <p:cNvPr id="12" name="TextBox 11"/>
+          <p:cNvSpPr txBox="1"/>
+          <p:nvPr/>
+        </p:nvSpPr>
+        <p:spPr>
+          <a:xfrm>
+            <a:off x="960120" y="4572000"/>
+            <a:ext cx="4663440" cy="1097280"/>
+          </a:xfrm>
+          <a:prstGeom prst="rect">
+            <a:avLst/>
+          </a:prstGeom>
+          <a:noFill/>
+        </p:spPr>
+        <p:txBody>
+          <a:bodyPr wrap="square">
+            <a:spAutoFit/>
+          </a:bodyPr>
+          <a:lstStyle/>
+          <a:p>
+            <a:pPr algn="l">
+              <a:spcBef>
+                <a:spcPts val="0"/>
+              </a:spcBef>
+              <a:spcAft>
+                <a:spcPts val="0"/>
+              </a:spcAft>
+            </a:pPr>
+            <a:r>
+              <a:rPr sz="1300" b="0" i="0">
+                <a:solidFill>
+                  <a:srgbClr val="555555"/>
+                </a:solidFill>
+                <a:latin typeface="Helvetica Neue"/>
+              </a:rPr>
+              <a:t>Schema validators, sanitizers, format parsers — consistent behavior across frontend, backend, and systems languages.</a:t>
+            </a:r>
+          </a:p>
+        </p:txBody>
+      </p:sp>
+      <p:sp>
+        <p:nvSpPr>
+          <p:cNvPr id="13" name="Rectangle 12"/>
+          <p:cNvSpPr/>
+          <p:nvPr/>
+        </p:nvSpPr>
+        <p:spPr>
+          <a:xfrm>
+            <a:off x="6400800" y="3931920"/>
+            <a:ext cx="5120640" cy="1828800"/>
+          </a:xfrm>
+          <a:prstGeom prst="rect">
+            <a:avLst/>
+          </a:prstGeom>
+          <a:solidFill>
+            <a:srgbClr val="FFFFFF"/>
+          </a:solidFill>
+          <a:ln w="9525">
+            <a:solidFill>
+              <a:srgbClr val="DDDDDD"/>
+            </a:solidFill>
+          </a:ln>
+        </p:spPr>
+        <p:style>
+          <a:lnRef idx="1">
+            <a:schemeClr val="accent1"/>
+          </a:lnRef>
+          <a:fillRef idx="3">
+            <a:schemeClr val="accent1"/>
+          </a:fillRef>
+          <a:effectRef idx="2">
+            <a:schemeClr val="accent1"/>
+          </a:effectRef>
+          <a:fontRef idx="minor">
+            <a:schemeClr val="lt1"/>
+          </a:fontRef>
+        </p:style>
+        <p:txBody>
+          <a:bodyPr rtlCol="0" anchor="ctr"/>
+          <a:lstStyle/>
+          <a:p>
+            <a:pPr algn="ctr"/>
+          </a:p>
+        </p:txBody>
+      </p:sp>
+      <p:sp>
+        <p:nvSpPr>
           <p:cNvPr id="14" name="TextBox 13"/>
           <p:cNvSpPr txBox="1"/>
           <p:nvPr/>
@@ -4687,7 +6528,7 @@
 </p:sld>
 </file>
 
-<file path=ppt/slides/slide12.xml><?xml version="1.0" encoding="utf-8"?>
+<file path=ppt/slides/slide15.xml><?xml version="1.0" encoding="utf-8"?>
 <p:sld xmlns:a="http://schemas.openxmlformats.org/drawingml/2006/main" xmlns:p="http://schemas.openxmlformats.org/presentationml/2006/main" xmlns:r="http://schemas.openxmlformats.org/officeDocument/2006/relationships">
   <p:cSld>
     <p:spTree>

</xml_diff>